<commit_message>
minor tweaks to a couple of slides
</commit_message>
<xml_diff>
--- a/PowerPoints/12 - Optimization.pptx
+++ b/PowerPoints/12 - Optimization.pptx
@@ -35,7 +35,7 @@
     <p:sldId id="272" r:id="rId23"/>
   </p:sldIdLst>
   <p:sldSz cx="9144000" cy="6858000" type="screen4x3"/>
-  <p:notesSz cx="7315200" cy="9601200"/>
+  <p:notesSz cx="7010400" cy="9296400"/>
   <p:defaultTextStyle>
     <a:defPPr>
       <a:defRPr lang="en-US"/>
@@ -178,12 +178,12 @@
     </p:ext>
     <p:ext uri="{2D200454-40CA-4A62-9FC3-DE9A4176ACB9}">
       <p15:notesGuideLst xmlns:p15="http://schemas.microsoft.com/office/powerpoint/2012/main">
-        <p15:guide id="1" orient="horz" pos="3024" userDrawn="1">
+        <p15:guide id="1" orient="horz" pos="2928" userDrawn="1">
           <p15:clr>
             <a:srgbClr val="A4A3A4"/>
           </p15:clr>
         </p15:guide>
-        <p15:guide id="2" pos="2304" userDrawn="1">
+        <p15:guide id="2" pos="2208" userDrawn="1">
           <p15:clr>
             <a:srgbClr val="A4A3A4"/>
           </p15:clr>
@@ -231,8 +231,8 @@
         </p:nvSpPr>
         <p:spPr bwMode="auto">
           <a:xfrm>
-            <a:off x="4143842" y="0"/>
-            <a:ext cx="3171358" cy="481045"/>
+            <a:off x="3971182" y="0"/>
+            <a:ext cx="3039218" cy="465774"/>
           </a:xfrm>
           <a:prstGeom prst="rect">
             <a:avLst/>
@@ -247,13 +247,13 @@
           <a:effectLst/>
         </p:spPr>
         <p:txBody>
-          <a:bodyPr vert="horz" wrap="square" lIns="96634" tIns="48316" rIns="96634" bIns="48316" numCol="1" anchor="t" anchorCtr="0" compatLnSpc="1">
+          <a:bodyPr vert="horz" wrap="square" lIns="93146" tIns="46572" rIns="93146" bIns="46572" numCol="1" anchor="t" anchorCtr="0" compatLnSpc="1">
             <a:prstTxWarp prst="textNoShape">
               <a:avLst/>
             </a:prstTxWarp>
           </a:bodyPr>
           <a:lstStyle>
-            <a:lvl1pPr algn="r" defTabSz="966322">
+            <a:lvl1pPr algn="r" defTabSz="931438">
               <a:defRPr sz="1200"/>
             </a:lvl1pPr>
           </a:lstStyle>
@@ -282,8 +282,8 @@
         </p:nvSpPr>
         <p:spPr bwMode="auto">
           <a:xfrm>
-            <a:off x="4143842" y="9120157"/>
-            <a:ext cx="3171358" cy="481044"/>
+            <a:off x="3971182" y="8830628"/>
+            <a:ext cx="3039218" cy="465773"/>
           </a:xfrm>
           <a:prstGeom prst="rect">
             <a:avLst/>
@@ -298,13 +298,13 @@
           <a:effectLst/>
         </p:spPr>
         <p:txBody>
-          <a:bodyPr vert="horz" wrap="square" lIns="96634" tIns="48316" rIns="96634" bIns="48316" numCol="1" anchor="b" anchorCtr="0" compatLnSpc="1">
+          <a:bodyPr vert="horz" wrap="square" lIns="93146" tIns="46572" rIns="93146" bIns="46572" numCol="1" anchor="b" anchorCtr="0" compatLnSpc="1">
             <a:prstTxWarp prst="textNoShape">
               <a:avLst/>
             </a:prstTxWarp>
           </a:bodyPr>
           <a:lstStyle>
-            <a:lvl1pPr algn="r" defTabSz="966322">
+            <a:lvl1pPr algn="r" defTabSz="931438">
               <a:defRPr sz="1200"/>
             </a:lvl1pPr>
           </a:lstStyle>
@@ -382,7 +382,7 @@
         <p:spPr bwMode="auto">
           <a:xfrm>
             <a:off x="2" y="0"/>
-            <a:ext cx="3171359" cy="481045"/>
+            <a:ext cx="3039219" cy="465774"/>
           </a:xfrm>
           <a:prstGeom prst="rect">
             <a:avLst/>
@@ -397,13 +397,13 @@
           <a:effectLst/>
         </p:spPr>
         <p:txBody>
-          <a:bodyPr vert="horz" wrap="square" lIns="96634" tIns="48316" rIns="96634" bIns="48316" numCol="1" anchor="t" anchorCtr="0" compatLnSpc="1">
+          <a:bodyPr vert="horz" wrap="square" lIns="93146" tIns="46572" rIns="93146" bIns="46572" numCol="1" anchor="t" anchorCtr="0" compatLnSpc="1">
             <a:prstTxWarp prst="textNoShape">
               <a:avLst/>
             </a:prstTxWarp>
           </a:bodyPr>
           <a:lstStyle>
-            <a:lvl1pPr algn="l" defTabSz="966322">
+            <a:lvl1pPr algn="l" defTabSz="931438">
               <a:defRPr sz="1200"/>
             </a:lvl1pPr>
           </a:lstStyle>
@@ -430,8 +430,8 @@
         </p:nvSpPr>
         <p:spPr bwMode="auto">
           <a:xfrm>
-            <a:off x="4143842" y="0"/>
-            <a:ext cx="3171358" cy="481045"/>
+            <a:off x="3971182" y="0"/>
+            <a:ext cx="3039218" cy="465774"/>
           </a:xfrm>
           <a:prstGeom prst="rect">
             <a:avLst/>
@@ -446,13 +446,13 @@
           <a:effectLst/>
         </p:spPr>
         <p:txBody>
-          <a:bodyPr vert="horz" wrap="square" lIns="96634" tIns="48316" rIns="96634" bIns="48316" numCol="1" anchor="t" anchorCtr="0" compatLnSpc="1">
+          <a:bodyPr vert="horz" wrap="square" lIns="93146" tIns="46572" rIns="93146" bIns="46572" numCol="1" anchor="t" anchorCtr="0" compatLnSpc="1">
             <a:prstTxWarp prst="textNoShape">
               <a:avLst/>
             </a:prstTxWarp>
           </a:bodyPr>
           <a:lstStyle>
-            <a:lvl1pPr algn="r" defTabSz="966322">
+            <a:lvl1pPr algn="r" defTabSz="931438">
               <a:defRPr sz="1200"/>
             </a:lvl1pPr>
           </a:lstStyle>
@@ -476,8 +476,8 @@
         </p:nvSpPr>
         <p:spPr bwMode="auto">
           <a:xfrm>
-            <a:off x="1257300" y="719138"/>
-            <a:ext cx="4800600" cy="3600450"/>
+            <a:off x="1181100" y="696913"/>
+            <a:ext cx="4648200" cy="3486150"/>
           </a:xfrm>
           <a:prstGeom prst="rect">
             <a:avLst/>
@@ -505,8 +505,8 @@
         </p:nvSpPr>
         <p:spPr bwMode="auto">
           <a:xfrm>
-            <a:off x="975803" y="4560898"/>
-            <a:ext cx="5363595" cy="4321197"/>
+            <a:off x="935145" y="4416108"/>
+            <a:ext cx="5140112" cy="4184016"/>
           </a:xfrm>
           <a:prstGeom prst="rect">
             <a:avLst/>
@@ -521,7 +521,7 @@
           <a:effectLst/>
         </p:spPr>
         <p:txBody>
-          <a:bodyPr vert="horz" wrap="square" lIns="96634" tIns="48316" rIns="96634" bIns="48316" numCol="1" anchor="t" anchorCtr="0" compatLnSpc="1">
+          <a:bodyPr vert="horz" wrap="square" lIns="93146" tIns="46572" rIns="93146" bIns="46572" numCol="1" anchor="t" anchorCtr="0" compatLnSpc="1">
             <a:prstTxWarp prst="textNoShape">
               <a:avLst/>
             </a:prstTxWarp>
@@ -576,8 +576,8 @@
         </p:nvSpPr>
         <p:spPr bwMode="auto">
           <a:xfrm>
-            <a:off x="2" y="9120157"/>
-            <a:ext cx="3171359" cy="481044"/>
+            <a:off x="2" y="8830628"/>
+            <a:ext cx="3039219" cy="465773"/>
           </a:xfrm>
           <a:prstGeom prst="rect">
             <a:avLst/>
@@ -592,13 +592,13 @@
           <a:effectLst/>
         </p:spPr>
         <p:txBody>
-          <a:bodyPr vert="horz" wrap="square" lIns="96634" tIns="48316" rIns="96634" bIns="48316" numCol="1" anchor="b" anchorCtr="0" compatLnSpc="1">
+          <a:bodyPr vert="horz" wrap="square" lIns="93146" tIns="46572" rIns="93146" bIns="46572" numCol="1" anchor="b" anchorCtr="0" compatLnSpc="1">
             <a:prstTxWarp prst="textNoShape">
               <a:avLst/>
             </a:prstTxWarp>
           </a:bodyPr>
           <a:lstStyle>
-            <a:lvl1pPr algn="l" defTabSz="966322">
+            <a:lvl1pPr algn="l" defTabSz="931438">
               <a:defRPr sz="1200"/>
             </a:lvl1pPr>
           </a:lstStyle>
@@ -622,8 +622,8 @@
         </p:nvSpPr>
         <p:spPr bwMode="auto">
           <a:xfrm>
-            <a:off x="4143842" y="9120157"/>
-            <a:ext cx="3171358" cy="481044"/>
+            <a:off x="3971182" y="8830628"/>
+            <a:ext cx="3039218" cy="465773"/>
           </a:xfrm>
           <a:prstGeom prst="rect">
             <a:avLst/>
@@ -638,13 +638,13 @@
           <a:effectLst/>
         </p:spPr>
         <p:txBody>
-          <a:bodyPr vert="horz" wrap="square" lIns="96634" tIns="48316" rIns="96634" bIns="48316" numCol="1" anchor="b" anchorCtr="0" compatLnSpc="1">
+          <a:bodyPr vert="horz" wrap="square" lIns="93146" tIns="46572" rIns="93146" bIns="46572" numCol="1" anchor="b" anchorCtr="0" compatLnSpc="1">
             <a:prstTxWarp prst="textNoShape">
               <a:avLst/>
             </a:prstTxWarp>
           </a:bodyPr>
           <a:lstStyle>
-            <a:lvl1pPr algn="r" defTabSz="966322">
+            <a:lvl1pPr algn="r" defTabSz="931438">
               <a:defRPr sz="1200"/>
             </a:lvl1pPr>
           </a:lstStyle>
@@ -4544,7 +4544,7 @@
               <a:rPr lang="en-US" dirty="0">
                 <a:latin typeface="Consolas" panose="020B0609020204030204" pitchFamily="49" charset="0"/>
               </a:rPr>
-              <a:t> XOR EAX </a:t>
+              <a:t> XOR EAX, EAX   </a:t>
             </a:r>
             <a:r>
               <a:rPr lang="en-US" dirty="0"/>
@@ -4678,15 +4678,7 @@
           <a:p>
             <a:r>
               <a:rPr lang="en-US" dirty="0"/>
-              <a:t>Detecting a common </a:t>
-            </a:r>
-            <a:r>
-              <a:rPr lang="en-US" dirty="0" err="1"/>
-              <a:t>subexpression</a:t>
-            </a:r>
-            <a:r>
-              <a:rPr lang="en-US" dirty="0"/>
-              <a:t>, evaluating it only once, and then referencing the common value</a:t>
+              <a:t>Detecting a common subexpression, evaluating it only once, and then referencing the common value</a:t>
             </a:r>
           </a:p>
           <a:p>
@@ -4869,7 +4861,7 @@
                 <a:latin typeface="Consolas" pitchFamily="49" charset="0"/>
                 <a:cs typeface="Consolas" pitchFamily="49" charset="0"/>
               </a:rPr>
-              <a:t>    j = j + (4+a[k])*PI+5;   // a is an array</a:t>
+              <a:t>    j = j + (4+a[k])*Pi+5;   // a is an array</a:t>
             </a:r>
           </a:p>
           <a:p>
@@ -4898,7 +4890,7 @@
               <a:t>	The calculation of “</a:t>
             </a:r>
             <a:r>
-              <a:rPr lang="en-US" dirty="0">
+              <a:rPr lang="en-US" sz="2300" dirty="0">
                 <a:latin typeface="Consolas" pitchFamily="49" charset="0"/>
                 <a:cs typeface="Consolas" pitchFamily="49" charset="0"/>
               </a:rPr>
@@ -4909,11 +4901,11 @@
               <a:t>” and “</a:t>
             </a:r>
             <a:r>
-              <a:rPr lang="en-US" dirty="0">
+              <a:rPr lang="en-US" sz="2300" dirty="0">
                 <a:latin typeface="Consolas" pitchFamily="49" charset="0"/>
                 <a:cs typeface="Consolas" pitchFamily="49" charset="0"/>
               </a:rPr>
-              <a:t>(4+a[k])*PI+5</a:t>
+              <a:t>(4+a[k])*Pi+5</a:t>
             </a:r>
             <a:r>
               <a:rPr lang="en-US" dirty="0"/>
@@ -4963,32 +4955,25 @@
               <a:buNone/>
             </a:pPr>
             <a:r>
+              <a:rPr lang="en-US" sz="1750" dirty="0">
+                <a:latin typeface="Consolas" pitchFamily="49" charset="0"/>
+                <a:cs typeface="Consolas" pitchFamily="49" charset="0"/>
+              </a:rPr>
+              <a:t>int </a:t>
+            </a:r>
+            <a:r>
               <a:rPr lang="en-US" sz="1750" dirty="0" err="1">
                 <a:latin typeface="Consolas" pitchFamily="49" charset="0"/>
                 <a:cs typeface="Consolas" pitchFamily="49" charset="0"/>
               </a:rPr>
-              <a:t>int</a:t>
+              <a:t>calcval</a:t>
             </a:r>
             <a:r>
               <a:rPr lang="en-US" sz="1750" dirty="0">
                 <a:latin typeface="Consolas" pitchFamily="49" charset="0"/>
                 <a:cs typeface="Consolas" pitchFamily="49" charset="0"/>
               </a:rPr>
-              <a:t> </a:t>
-            </a:r>
-            <a:r>
-              <a:rPr lang="en-US" sz="1750" dirty="0" err="1">
-                <a:latin typeface="Consolas" pitchFamily="49" charset="0"/>
-                <a:cs typeface="Consolas" pitchFamily="49" charset="0"/>
-              </a:rPr>
-              <a:t>calcval</a:t>
-            </a:r>
-            <a:r>
-              <a:rPr lang="en-US" sz="1750" dirty="0">
-                <a:latin typeface="Consolas" pitchFamily="49" charset="0"/>
-                <a:cs typeface="Consolas" pitchFamily="49" charset="0"/>
-              </a:rPr>
-              <a:t> = (4+a[k])*PI+5;</a:t>
+              <a:t> = (4+a[k])*Pi+5;</a:t>
             </a:r>
           </a:p>
           <a:p>
@@ -5508,7 +5493,7 @@
           <a:p>
             <a:r>
               <a:rPr lang="en-US" dirty="0"/>
-              <a:t>Note that dead code elimination affects only the size of the generated code, not the speed at which it executes.</a:t>
+              <a:t>Note that dead code elimination usually affects only the size of the generated code, not the speed at which it executes.</a:t>
             </a:r>
           </a:p>
         </p:txBody>
@@ -7537,9 +7522,10 @@
               <a:rPr lang="en-US" dirty="0"/>
             </a:br>
             <a:r>
-              <a:rPr lang="en-US" dirty="0"/>
-              <a:t>(peephole optimizer)</a:t>
-            </a:r>
+              <a:rPr lang="en-US" sz="2400" dirty="0"/>
+              <a:t>(uses a peephole optimizer)</a:t>
+            </a:r>
+            <a:endParaRPr lang="en-US" dirty="0"/>
           </a:p>
         </p:txBody>
       </p:sp>
@@ -7577,7 +7563,7 @@
               <a:buNone/>
             </a:pPr>
             <a:r>
-              <a:rPr lang="en-US" sz="1900" dirty="0">
+              <a:rPr lang="en-US" sz="1800" dirty="0">
                 <a:latin typeface="Consolas" panose="020B0609020204030204" pitchFamily="49" charset="0"/>
               </a:rPr>
               <a:t>LDCINT 5</a:t>
@@ -7591,7 +7577,7 @@
               <a:buNone/>
             </a:pPr>
             <a:r>
-              <a:rPr lang="en-US" sz="1900" dirty="0">
+              <a:rPr lang="en-US" sz="1800" dirty="0">
                 <a:latin typeface="Consolas" panose="020B0609020204030204" pitchFamily="49" charset="0"/>
               </a:rPr>
               <a:t>LDCINT 7     –&gt;   LDCINT 12</a:t>
@@ -7605,7 +7591,7 @@
               <a:buNone/>
             </a:pPr>
             <a:r>
-              <a:rPr lang="en-US" sz="1900" dirty="0">
+              <a:rPr lang="en-US" sz="1800" dirty="0">
                 <a:latin typeface="Consolas" panose="020B0609020204030204" pitchFamily="49" charset="0"/>
               </a:rPr>
               <a:t>ADD</a:t>
@@ -7620,46 +7606,47 @@
           <a:p>
             <a:pPr lvl="1"/>
             <a:r>
-              <a:rPr lang="en-US" sz="1900" dirty="0"/>
+              <a:rPr lang="en-US" dirty="0"/>
               <a:t>use </a:t>
             </a:r>
             <a:r>
-              <a:rPr lang="en-US" sz="1900" dirty="0" err="1">
+              <a:rPr lang="en-US" dirty="0" err="1">
                 <a:latin typeface="Consolas" panose="020B0609020204030204" pitchFamily="49" charset="0"/>
               </a:rPr>
               <a:t>inc</a:t>
             </a:r>
             <a:r>
-              <a:rPr lang="en-US" sz="1900" dirty="0"/>
+              <a:rPr lang="en-US" dirty="0"/>
               <a:t> and dec</a:t>
             </a:r>
           </a:p>
           <a:p>
             <a:pPr lvl="1"/>
             <a:r>
-              <a:rPr lang="en-US" sz="1900" dirty="0"/>
+              <a:rPr lang="en-US" dirty="0"/>
               <a:t>use special constant instructions </a:t>
             </a:r>
             <a:r>
-              <a:rPr lang="en-US" sz="1900" dirty="0">
+              <a:rPr lang="en-US" sz="1800" dirty="0">
                 <a:latin typeface="Consolas" panose="020B0609020204030204" pitchFamily="49" charset="0"/>
               </a:rPr>
               <a:t>LDCINT0</a:t>
             </a:r>
             <a:r>
-              <a:rPr lang="en-US" sz="1900" dirty="0"/>
+              <a:rPr lang="en-US" dirty="0"/>
               <a:t>, </a:t>
             </a:r>
             <a:r>
-              <a:rPr lang="en-US" sz="1900" dirty="0">
+              <a:rPr lang="en-US" sz="1800" dirty="0">
                 <a:latin typeface="Consolas" panose="020B0609020204030204" pitchFamily="49" charset="0"/>
               </a:rPr>
               <a:t>LDCINT1</a:t>
             </a:r>
             <a:r>
-              <a:rPr lang="en-US" sz="1900" dirty="0"/>
+              <a:rPr lang="en-US" dirty="0"/>
               <a:t>, etc.</a:t>
             </a:r>
+            <a:endParaRPr lang="en-US" sz="1900" dirty="0"/>
           </a:p>
           <a:p>
             <a:r>
@@ -7675,7 +7662,7 @@
               <a:buNone/>
             </a:pPr>
             <a:r>
-              <a:rPr lang="en-US" sz="1900" dirty="0">
+              <a:rPr lang="en-US" sz="1800" dirty="0">
                 <a:latin typeface="Consolas" panose="020B0609020204030204" pitchFamily="49" charset="0"/>
               </a:rPr>
               <a:t>RET 4</a:t>
@@ -7689,11 +7676,33 @@
               <a:buNone/>
             </a:pPr>
             <a:r>
-              <a:rPr lang="en-US" sz="1900" dirty="0">
+              <a:rPr lang="en-US" sz="1800" dirty="0">
                 <a:latin typeface="Consolas" panose="020B0609020204030204" pitchFamily="49" charset="0"/>
               </a:rPr>
               <a:t>BR L7    –&gt; unreachable and can be removed</a:t>
             </a:r>
+          </a:p>
+          <a:p>
+            <a:pPr marL="347472">
+              <a:spcBef>
+                <a:spcPts val="600"/>
+              </a:spcBef>
+            </a:pPr>
+            <a:r>
+              <a:rPr lang="en-US" dirty="0"/>
+              <a:t>... others</a:t>
+            </a:r>
+          </a:p>
+          <a:p>
+            <a:pPr marL="514350" lvl="1" indent="0">
+              <a:spcBef>
+                <a:spcPts val="200"/>
+              </a:spcBef>
+              <a:buNone/>
+            </a:pPr>
+            <a:endParaRPr lang="en-US" sz="1900" dirty="0">
+              <a:latin typeface="Consolas" panose="020B0609020204030204" pitchFamily="49" charset="0"/>
+            </a:endParaRPr>
           </a:p>
         </p:txBody>
       </p:sp>

</xml_diff>